<commit_message>
Set up first modern switching lesson flow
</commit_message>
<xml_diff>
--- a/主动引导智能体介绍/主动引导智能体介绍.pptx
+++ b/主动引导智能体介绍/主动引导智能体介绍.pptx
@@ -14102,7 +14102,7 @@
   <p:cSld>
     <p:spTree>
       <p:nvGrpSpPr>
-        <p:cNvPr id="153" name="" descr="&lt;Slide style={{ width: '1280px', height: '720px', padding: 0, background: '#FFFFFF' }}&gt;&#10;  &lt;Box style={{ position: 'absolute', top: 36, left: 64, right: 64, flexDirection: 'row', gap: 16 }}&gt;&#10;    &lt;Box style={{ width: 8, height: 40, background: '#1B4F9C', borderRadius: 2, marginTop: 4 }} /&gt;&#10;    &lt;Box&gt;&#10;      &lt;Text style={{ fontSize: 34, fontWeight: 'bold', color: '#0F2E5C' }}&gt;一节课的六幕：时间表就是剧本&lt;/Text&gt;&#10;      &lt;Text style={{ fontSize: 15, color: '#64748B', marginTop: 6 }}&gt;以 45 分钟示例课《第3章 处理机调度》为例 —— 时长占比来自 lesson-plan.json 真实配置&lt;/Text&gt;&#10;    &lt;/Box&gt;&#10;  &lt;/Box&gt;&#10;  &lt;Box style={{ position: 'absolute', top: 128, left: 64, right: 64 }}&gt;&#10;    &lt;svg width={1152} height={500} viewBox=&quot;0 0 1152 500&quot;&gt;&#10;      &lt;text x={80} y={40} fontSize={14} fill=&quot;#64748B&quot;&gt;0%&lt;/text&gt;&#10;      &lt;text x={320} y={40} fontSize={14} fill=&quot;#64748B&quot;&gt;50%&lt;/text&gt;&#10;      &lt;text x={535} y={40} fontSize={14} fill=&quot;#64748B&quot;&gt;70%&lt;/text&gt;&#10;      &lt;text x={700} y={40} fontSize={14} fill=&quot;#64748B&quot;&gt;85%&lt;/text&gt;&#10;      &lt;text x={880} y={40} fontSize={14} fill=&quot;#64748B&quot;&gt;100%&lt;/text&gt;&#10;      &lt;rect x={40} y={60} width={44} height={92} rx={8} fill=&quot;#64748B&quot; /&gt;&#10;      &lt;text x={62} y={108} fontSize={13} fill=&quot;#FFFFFF&quot; textAnchor=&quot;middle&quot; fontWeight=&quot;bold&quot;&gt;开场&lt;/text&gt;&#10;      &lt;rect x={88} y={60} width={488} height={92} rx={8} fill=&quot;#1B4F9C&quot; /&gt;&#10;      &lt;text x={332} y={100} fontSize={18} fill=&quot;#FFFFFF&quot; textAnchor=&quot;middle&quot; fontWeight=&quot;bold&quot;&gt;引导学习 · 讲解 + 主动提问&lt;/text&gt;&#10;      &lt;text x={332} y={128} fontSize={15} fill=&quot;#BFD4F2&quot; textAnchor=&quot;middle&quot;&gt;22 分钟&lt;/text&gt;&#10;      &lt;rect x={580} y={60} width={200} height={92} rx={8} fill=&quot;#3D7BE0&quot; /&gt;&#10;      &lt;text x={680} y={100} fontSize={17} fill=&quot;#FFFFFF&quot; textAnchor=&quot;middle&quot; fontWeight=&quot;bold&quot;&gt;复述与讨论&lt;/text&gt;&#10;      &lt;text x={680} y={128} fontSize={15} fill=&quot;#D6E4F8&quot; textAnchor=&quot;middle&quot;&gt;9 分钟&lt;/text&gt;&#10;      &lt;rect x={784} y={60} width={155} height={92} rx={8} fill=&quot;#1B4F9C&quot; /&gt;&#10;      &lt;text x={861} y={100} fontSize={17} fill=&quot;#FFFFFF&quot; textAnchor=&quot;middle&quot; fontWeight=&quot;bold&quot;&gt;深层探究&lt;/text&gt;&#10;      &lt;text x={861} y={128} fontSize={15} fill=&quot;#BFD4F2&quot; textAnchor=&quot;middle&quot;&gt;7 分钟&lt;/text&gt;&#10;      &lt;rect x={943} y={60} width={155} height={92} rx={8} fill=&quot;#E8F0FB&quot; stroke=&quot;#1B4F9C&quot; strokeWidth={2} strokeDasharray=&quot;8 6&quot; /&gt;&#10;      &lt;text x={1020} y={100} fontSize={16} fill=&quot;#1B4F9C&quot; textAnchor=&quot;middle&quot; fontWeight=&quot;bold&quot;&gt;全班讨论&lt;/text&gt;&#10;      &lt;text x={1020} y={128} fontSize={13} fill=&quot;#64748B&quot; textAnchor=&quot;middle&quot;&gt;7′ 本课已停用&lt;/text&gt;&#10;      &lt;rect x={1102} y={60} width={44} height={92} rx={8} fill=&quot;#64748B&quot; /&gt;&#10;      &lt;text x={1124} y={108} fontSize={13} fill=&quot;#FFFFFF&quot; textAnchor=&quot;middle&quot; fontWeight=&quot;bold&quot;&gt;收尾&lt;/text&gt;&#10;      &lt;path d=&quot;M332 156 L332 180&quot; stroke=&quot;#F59E0B&quot; strokeWidth={2.5} /&gt;&#10;      &lt;text x={332} y={204} fontSize={15} fill=&quot;#F59E0B&quot; textAnchor=&quot;middle&quot; fontWeight=&quot;bold&quot;&gt;1 星「已接触」&lt;/text&gt;&#10;      &lt;path d=&quot;M680 156 L680 180&quot; stroke=&quot;#F59E0B&quot; strokeWidth={2.5} /&gt;&#10;      &lt;text x={680} y={204} fontSize={15} fill=&quot;#F59E0B&quot; textAnchor=&quot;middle&quot; fontWeight=&quot;bold&quot;&gt;2–3 星&lt;/text&gt;&#10;      &lt;path d=&quot;M861 156 L861 180&quot; stroke=&quot;#F59E0B&quot; strokeWidth={2.5} /&gt;&#10;      &lt;text x={861} y={204} fontSize={15} fill=&quot;#F59E0B&quot; textAnchor=&quot;middle&quot; fontWeight=&quot;bold&quot;&gt;4 星&lt;/text&gt;&#10;      &lt;text x={1020} y={204} fontSize={13} fill=&quot;#64748B&quot; textAnchor=&quot;middle&quot;&gt;只记快照&lt;/text&gt;&#10;      &lt;rect x={40} y={240} width={1106} height={2} fill=&quot;#D7E4F6&quot; /&gt;&#10;      &lt;rect x={40} y={270} width={1106} height={86} rx={12} fill=&quot;#E8F0FB&quot; /&gt;&#10;      &lt;text x={64} y={306} fontSize={17} fill=&quot;#0F2E5C&quot;&gt;幕可自由启停：lesson-plan.json 里 &lt;tspan fontWeight=&quot;bold&quot;&gt;enabled: false&lt;/tspan&gt; 即整段跳过（本课关掉了全班讨论）&lt;/text&gt;&#10;      &lt;text x={64} y={336} fontSize={14} fill=&quot;#64748B&quot;&gt;intro / ending 是系统幕，不占老师的时间预算；中间各幕分钟数之和 ≤ 总时长，开课前由 8 项校验把关&lt;/text&gt;&#10;      &lt;rect x={40} y={386} width={1106} height={86} rx={12} fill=&quot;#FFFFFF&quot; stroke=&quot;#D7E4F6&quot; /&gt;&#10;      &lt;text x={64} y={422} fontSize={17} fill=&quot;#0F2E5C&quot;&gt;时间表不是估算：&lt;tspan fontWeight=&quot;bold&quot; fill=&quot;#1B4F9C&quot;&gt;编排器对真实墙上时钟负责&lt;/tspan&gt;，不数「聊了几轮」&lt;/text&gt;&#10;      &lt;text x={64} y={452} fontSize={14} fill=&quot;#64748B&quot;&gt;到点（minutes 预算耗尽）按 advance_policy 切幕：立即切 / 收尾后切 / 允许延长 ≤3 分钟&lt;/text&gt;&#10;    &lt;/svg&gt;&#10;  &lt;/Box&gt;&#10;  &lt;Box style={{ position: 'absolute', left: 64, right: 64, bottom: 20, flexDirection: 'row', justifyContent: 'space-between' }}&gt;&#10;    &lt;Box style={{ flexDirection: 'row', alignItems: 'center', gap: 8 }}&gt;&#10;      &lt;Box style={{ width: 10, height: 10, background: '#1B4F9C', borderRadius: 2 }} /&gt;&#10;      &lt;Text style={{ fontSize: 13, color: '#64748B' }}&gt;主动引导智能体 · 项目介绍&lt;/Text&gt;&#10;    &lt;/Box&gt;&#10;    &lt;Text style={{ fontSize: 13, color: '#64748B' }}&gt;04 / 18&lt;/Text&gt;&#10;  &lt;/Box&gt;&#10;&lt;/Slide&gt;&#10;"/>
+        <p:cNvPr id="153" name="" descr="&lt;Slide style={{ width: '1280px', height: '720px', padding: 0, background: '#FFFFFF' }}&gt;&#10;  &lt;Box style={{ position: 'absolute', top: 36, left: 64, right: 64, flexDirection: 'row', gap: 16 }}&gt;&#10;    &lt;Box style={{ width: 8, height: 40, background: '#1B4F9C', borderRadius: 2, marginTop: 4 }} /&gt;&#10;    &lt;Box&gt;&#10;      &lt;Text style={{ fontSize: 34, fontWeight: 'bold', color: '#0F2E5C' }}&gt;一节课的六幕：时间表就是剧本&lt;/Text&gt;&#10;      &lt;Text style={{ fontSize: 15, color: '#64748B', marginTop: 6 }}&gt;以 45 分钟示例课《第3章 示例课时》为例 —— 时长占比来自 lesson-plan.json 真实配置&lt;/Text&gt;&#10;    &lt;/Box&gt;&#10;  &lt;/Box&gt;&#10;  &lt;Box style={{ position: 'absolute', top: 128, left: 64, right: 64 }}&gt;&#10;    &lt;svg width={1152} height={500} viewBox=&quot;0 0 1152 500&quot;&gt;&#10;      &lt;text x={80} y={40} fontSize={14} fill=&quot;#64748B&quot;&gt;0%&lt;/text&gt;&#10;      &lt;text x={320} y={40} fontSize={14} fill=&quot;#64748B&quot;&gt;50%&lt;/text&gt;&#10;      &lt;text x={535} y={40} fontSize={14} fill=&quot;#64748B&quot;&gt;70%&lt;/text&gt;&#10;      &lt;text x={700} y={40} fontSize={14} fill=&quot;#64748B&quot;&gt;85%&lt;/text&gt;&#10;      &lt;text x={880} y={40} fontSize={14} fill=&quot;#64748B&quot;&gt;100%&lt;/text&gt;&#10;      &lt;rect x={40} y={60} width={44} height={92} rx={8} fill=&quot;#64748B&quot; /&gt;&#10;      &lt;text x={62} y={108} fontSize={13} fill=&quot;#FFFFFF&quot; textAnchor=&quot;middle&quot; fontWeight=&quot;bold&quot;&gt;开场&lt;/text&gt;&#10;      &lt;rect x={88} y={60} width={488} height={92} rx={8} fill=&quot;#1B4F9C&quot; /&gt;&#10;      &lt;text x={332} y={100} fontSize={18} fill=&quot;#FFFFFF&quot; textAnchor=&quot;middle&quot; fontWeight=&quot;bold&quot;&gt;引导学习 · 讲解 + 主动提问&lt;/text&gt;&#10;      &lt;text x={332} y={128} fontSize={15} fill=&quot;#BFD4F2&quot; textAnchor=&quot;middle&quot;&gt;22 分钟&lt;/text&gt;&#10;      &lt;rect x={580} y={60} width={200} height={92} rx={8} fill=&quot;#3D7BE0&quot; /&gt;&#10;      &lt;text x={680} y={100} fontSize={17} fill=&quot;#FFFFFF&quot; textAnchor=&quot;middle&quot; fontWeight=&quot;bold&quot;&gt;复述与讨论&lt;/text&gt;&#10;      &lt;text x={680} y={128} fontSize={15} fill=&quot;#D6E4F8&quot; textAnchor=&quot;middle&quot;&gt;9 分钟&lt;/text&gt;&#10;      &lt;rect x={784} y={60} width={155} height={92} rx={8} fill=&quot;#1B4F9C&quot; /&gt;&#10;      &lt;text x={861} y={100} fontSize={17} fill=&quot;#FFFFFF&quot; textAnchor=&quot;middle&quot; fontWeight=&quot;bold&quot;&gt;深层探究&lt;/text&gt;&#10;      &lt;text x={861} y={128} fontSize={15} fill=&quot;#BFD4F2&quot; textAnchor=&quot;middle&quot;&gt;7 分钟&lt;/text&gt;&#10;      &lt;rect x={943} y={60} width={155} height={92} rx={8} fill=&quot;#E8F0FB&quot; stroke=&quot;#1B4F9C&quot; strokeWidth={2} strokeDasharray=&quot;8 6&quot; /&gt;&#10;      &lt;text x={1020} y={100} fontSize={16} fill=&quot;#1B4F9C&quot; textAnchor=&quot;middle&quot; fontWeight=&quot;bold&quot;&gt;全班讨论&lt;/text&gt;&#10;      &lt;text x={1020} y={128} fontSize={13} fill=&quot;#64748B&quot; textAnchor=&quot;middle&quot;&gt;7′ 本课已停用&lt;/text&gt;&#10;      &lt;rect x={1102} y={60} width={44} height={92} rx={8} fill=&quot;#64748B&quot; /&gt;&#10;      &lt;text x={1124} y={108} fontSize={13} fill=&quot;#FFFFFF&quot; textAnchor=&quot;middle&quot; fontWeight=&quot;bold&quot;&gt;收尾&lt;/text&gt;&#10;      &lt;path d=&quot;M332 156 L332 180&quot; stroke=&quot;#F59E0B&quot; strokeWidth={2.5} /&gt;&#10;      &lt;text x={332} y={204} fontSize={15} fill=&quot;#F59E0B&quot; textAnchor=&quot;middle&quot; fontWeight=&quot;bold&quot;&gt;1 星「已接触」&lt;/text&gt;&#10;      &lt;path d=&quot;M680 156 L680 180&quot; stroke=&quot;#F59E0B&quot; strokeWidth={2.5} /&gt;&#10;      &lt;text x={680} y={204} fontSize={15} fill=&quot;#F59E0B&quot; textAnchor=&quot;middle&quot; fontWeight=&quot;bold&quot;&gt;2–3 星&lt;/text&gt;&#10;      &lt;path d=&quot;M861 156 L861 180&quot; stroke=&quot;#F59E0B&quot; strokeWidth={2.5} /&gt;&#10;      &lt;text x={861} y={204} fontSize={15} fill=&quot;#F59E0B&quot; textAnchor=&quot;middle&quot; fontWeight=&quot;bold&quot;&gt;4 星&lt;/text&gt;&#10;      &lt;text x={1020} y={204} fontSize={13} fill=&quot;#64748B&quot; textAnchor=&quot;middle&quot;&gt;只记快照&lt;/text&gt;&#10;      &lt;rect x={40} y={240} width={1106} height={2} fill=&quot;#D7E4F6&quot; /&gt;&#10;      &lt;rect x={40} y={270} width={1106} height={86} rx={12} fill=&quot;#E8F0FB&quot; /&gt;&#10;      &lt;text x={64} y={306} fontSize={17} fill=&quot;#0F2E5C&quot;&gt;幕可自由启停：lesson-plan.json 里 &lt;tspan fontWeight=&quot;bold&quot;&gt;enabled: false&lt;/tspan&gt; 即整段跳过（本课关掉了全班讨论）&lt;/text&gt;&#10;      &lt;text x={64} y={336} fontSize={14} fill=&quot;#64748B&quot;&gt;intro / ending 是系统幕，不占老师的时间预算；中间各幕分钟数之和 ≤ 总时长，开课前由 8 项校验把关&lt;/text&gt;&#10;      &lt;rect x={40} y={386} width={1106} height={86} rx={12} fill=&quot;#FFFFFF&quot; stroke=&quot;#D7E4F6&quot; /&gt;&#10;      &lt;text x={64} y={422} fontSize={17} fill=&quot;#0F2E5C&quot;&gt;时间表不是估算：&lt;tspan fontWeight=&quot;bold&quot; fill=&quot;#1B4F9C&quot;&gt;编排器对真实墙上时钟负责&lt;/tspan&gt;，不数「聊了几轮」&lt;/text&gt;&#10;      &lt;text x={64} y={452} fontSize={14} fill=&quot;#64748B&quot;&gt;到点（minutes 预算耗尽）按 advance_policy 切幕：立即切 / 收尾后切 / 允许延长 ≤3 分钟&lt;/text&gt;&#10;    &lt;/svg&gt;&#10;  &lt;/Box&gt;&#10;  &lt;Box style={{ position: 'absolute', left: 64, right: 64, bottom: 20, flexDirection: 'row', justifyContent: 'space-between' }}&gt;&#10;    &lt;Box style={{ flexDirection: 'row', alignItems: 'center', gap: 8 }}&gt;&#10;      &lt;Box style={{ width: 10, height: 10, background: '#1B4F9C', borderRadius: 2 }} /&gt;&#10;      &lt;Text style={{ fontSize: 13, color: '#64748B' }}&gt;主动引导智能体 · 项目介绍&lt;/Text&gt;&#10;    &lt;/Box&gt;&#10;    &lt;Text style={{ fontSize: 13, color: '#64748B' }}&gt;04 / 18&lt;/Text&gt;&#10;  &lt;/Box&gt;&#10;&lt;/Slide&gt;&#10;"/>
         <p:cNvGrpSpPr/>
         <p:nvPr/>
       </p:nvGrpSpPr>
@@ -14296,7 +14296,7 @@
                 <a:latin typeface="微软雅黑" panose="020B0503020204020204" charset="-122"/>
                 <a:ea typeface="微软雅黑" panose="020B0503020204020204" charset="-122"/>
               </a:rPr>
-              <a:t>处理机调度》为例</a:t>
+              <a:t>示例课时》为例</a:t>
             </a:r>
             <a:r>
               <a:rPr lang="en-US" sz="1125">
@@ -16590,7 +16590,7 @@
   <p:cSld>
     <p:spTree>
       <p:nvGrpSpPr>
-        <p:cNvPr id="179" name="" descr="&lt;Slide style={{ width: '1280px', height: '720px', padding: 0, background: '#FFFFFF' }}&gt;&#10;  &lt;Box style={{ position: 'absolute', top: 36, left: 64, right: 64, flexDirection: 'row', gap: 16 }}&gt;&#10;    &lt;Box style={{ width: 8, height: 40, background: '#1B4F9C', borderRadius: 2, marginTop: 4 }} /&gt;&#10;    &lt;Box&gt;&#10;      &lt;Text style={{ fontSize: 34, fontWeight: 'bold', color: '#0F2E5C' }}&gt;第一步：lesson-plan.json 定阶段与时长&lt;/Text&gt;&#10;      &lt;Text style={{ fontSize: 15, color: '#64748B', marginTop: 6 }}&gt;lesson-data/lesson-plan.json —— 编排入口，load_plan 节点开课时读取并校验&lt;/Text&gt;&#10;    &lt;/Box&gt;&#10;  &lt;/Box&gt;&#10;  &lt;Box style={{ position: 'absolute', top: 128, left: 64, right: 64, bottom: 56, flexDirection: 'row', gap: 28 }}&gt;&#10;    &lt;Box style={{ width: '54%' }}&gt;&#10;      &lt;CodeBlock&#10;        language='json'&#10;        theme='github-light'&#10;        fontSize={12.5}&#10;        width={610}&#10;        code={`{&#10;  &quot;lesson_id&quot;: &quot;ch3-process-scheduling&quot;,&#10;  &quot;total_minutes&quot;: 45,&#10;  &quot;stages&quot;: [&#10;    { &quot;id&quot;: &quot;guided_learning&quot;,  &quot;enabled&quot;: true,&#10;      &quot;minutes&quot;: 22, &quot;advance_when&quot;: &quot;either&quot; },&#10;    { &quot;id&quot;: &quot;recap_discussion&quot;, &quot;enabled&quot;: true,&#10;      &quot;minutes&quot;: 9,  &quot;advance_when&quot;: &quot;either&quot; },&#10;    { &quot;id&quot;: &quot;deep_inquiry&quot;,     &quot;enabled&quot;: true,&#10;      &quot;minutes&quot;: 7,  &quot;advance_when&quot;: &quot;either&quot; },&#10;    { &quot;id&quot;: &quot;class_discussion&quot;, &quot;enabled&quot;: false,&#10;      &quot;minutes&quot;: 7,  &quot;advance_when&quot;: &quot;budget&quot; }&#10;  ],&#10;  &quot;advance_policy&quot;: {&#10;    &quot;on_budget_exhausted&quot;: &quot;wrap_up&quot;,  // 到点:收尾后切&#10;    &quot;on_evidence_reached&quot;: &quot;advance&quot;,  // 证据达标:切幕&#10;    &quot;min_stage_minutes&quot;: 2,            // 防秒切&#10;    &quot;max_stage_overrun_minutes&quot;: 3     // 延长上限&#10;  }&#10;}`}&#10;      /&gt;&#10;    &lt;/Box&gt;&#10;    &lt;Box style={{ flex: 1, gap: 14 }}&gt;&#10;      &lt;Table&#10;        style={{ width: '100%', height: 230 }}&#10;        defaultTextStyle={{ fontSize: 13.5, textAlign: 'left', color: '#0F2E5C' }}&#10;        defaultCellStyle={{ border: { bottom: { width: 1, color: '#D7E4F6' } }, padding: 7 }}&#10;        cells={[&#10;          [&#10;            { text: '字段', textStyle: { bold: true, color: '#FFFFFF' }, cellStyle: { background: { color: '#1B4F9C' } } },&#10;            { text: '含义', textStyle: { bold: true, color: '#FFFFFF' }, cellStyle: { background: { color: '#1B4F9C' } } },&#10;          ],&#10;          [&#10;            { text: 'enabled', textStyle: { bold: true, color: '#1B4F9C' } },&#10;            'false → 整段跳过（这门课可以不要讨论）',&#10;          ],&#10;          [&#10;            { text: 'minutes', textStyle: { bold: true, color: '#1B4F9C' }, cellStyle: { background: { color: '#E8F0FB' } } },&#10;            { text: '这一幕的时长预算，真实时钟到点切幕', cellStyle: { background: { color: '#E8F0FB' } } },&#10;          ],&#10;          [&#10;            { text: 'advance_when', textStyle: { bold: true, color: '#1B4F9C' } },&#10;            'either 证据或时间 / evidence 学透才走 / budget 只看时间',&#10;          ],&#10;        ]}&#10;      /&gt;&#10;      &lt;Box style={{ background: '#E8F0FB', borderRadius: 10, padding: '14px 18px', marginTop: 'auto' }}&gt;&#10;        &lt;Text style={{ fontSize: 14.5, color: '#0F2E5C', lineHeight: 1.65 }}&gt;&#10;          &lt;span style={{ fontWeight: 'bold', color: '#1B4F9C' }}&gt;改 JSON 就是改课。&lt;/span&gt;加一幕、砍一幕、调整分钟数，都不用碰任何代码与提示词 —— 状态机每轮读这张表。&#10;        &lt;/Text&gt;&#10;      &lt;/Box&gt;&#10;    &lt;/Box&gt;&#10;  &lt;/Box&gt;&#10;  &lt;Box style={{ position: 'absolute', left: 64, right: 64, bottom: 20, flexDirection: 'row', justifyContent: 'space-between' }}&gt;&#10;    &lt;Box style={{ flexDirection: 'row', alignItems: 'center', gap: 8 }}&gt;&#10;      &lt;Box style={{ width: 10, height: 10, background: '#1B4F9C', borderRadius: 2 }} /&gt;&#10;      &lt;Text style={{ fontSize: 13, color: '#64748B' }}&gt;主动引导智能体 · 项目介绍&lt;/Text&gt;&#10;    &lt;/Box&gt;&#10;    &lt;Text style={{ fontSize: 13, color: '#64748B' }}&gt;07 / 18&lt;/Text&gt;&#10;  &lt;/Box&gt;&#10;&lt;/Slide&gt;&#10;"/>
+        <p:cNvPr id="179" name="" descr="&lt;Slide style={{ width: '1280px', height: '720px', padding: 0, background: '#FFFFFF' }}&gt;&#10;  &lt;Box style={{ position: 'absolute', top: 36, left: 64, right: 64, flexDirection: 'row', gap: 16 }}&gt;&#10;    &lt;Box style={{ width: 8, height: 40, background: '#1B4F9C', borderRadius: 2, marginTop: 4 }} /&gt;&#10;    &lt;Box&gt;&#10;      &lt;Text style={{ fontSize: 34, fontWeight: 'bold', color: '#0F2E5C' }}&gt;第一步：lesson-plan.json 定阶段与时长&lt;/Text&gt;&#10;      &lt;Text style={{ fontSize: 15, color: '#64748B', marginTop: 6 }}&gt;lesson-data/lesson-plan.json —— 编排入口，load_plan 节点开课时读取并校验&lt;/Text&gt;&#10;    &lt;/Box&gt;&#10;  &lt;/Box&gt;&#10;  &lt;Box style={{ position: 'absolute', top: 128, left: 64, right: 64, bottom: 56, flexDirection: 'row', gap: 28 }}&gt;&#10;    &lt;Box style={{ width: '54%' }}&gt;&#10;      &lt;CodeBlock&#10;        language='json'&#10;        theme='github-light'&#10;        fontSize={12.5}&#10;        width={610}&#10;        code={`{&#10;  &quot;lesson_id&quot;: &quot;example-week-1&quot;,&#10;  &quot;total_minutes&quot;: 45,&#10;  &quot;stages&quot;: [&#10;    { &quot;id&quot;: &quot;guided_learning&quot;,  &quot;enabled&quot;: true,&#10;      &quot;minutes&quot;: 22, &quot;advance_when&quot;: &quot;either&quot; },&#10;    { &quot;id&quot;: &quot;recap_discussion&quot;, &quot;enabled&quot;: true,&#10;      &quot;minutes&quot;: 9,  &quot;advance_when&quot;: &quot;either&quot; },&#10;    { &quot;id&quot;: &quot;deep_inquiry&quot;,     &quot;enabled&quot;: true,&#10;      &quot;minutes&quot;: 7,  &quot;advance_when&quot;: &quot;either&quot; },&#10;    { &quot;id&quot;: &quot;class_discussion&quot;, &quot;enabled&quot;: false,&#10;      &quot;minutes&quot;: 7,  &quot;advance_when&quot;: &quot;budget&quot; }&#10;  ],&#10;  &quot;advance_policy&quot;: {&#10;    &quot;on_budget_exhausted&quot;: &quot;wrap_up&quot;,  // 到点:收尾后切&#10;    &quot;on_evidence_reached&quot;: &quot;advance&quot;,  // 证据达标:切幕&#10;    &quot;min_stage_minutes&quot;: 2,            // 防秒切&#10;    &quot;max_stage_overrun_minutes&quot;: 3     // 延长上限&#10;  }&#10;}`}&#10;      /&gt;&#10;    &lt;/Box&gt;&#10;    &lt;Box style={{ flex: 1, gap: 14 }}&gt;&#10;      &lt;Table&#10;        style={{ width: '100%', height: 230 }}&#10;        defaultTextStyle={{ fontSize: 13.5, textAlign: 'left', color: '#0F2E5C' }}&#10;        defaultCellStyle={{ border: { bottom: { width: 1, color: '#D7E4F6' } }, padding: 7 }}&#10;        cells={[&#10;          [&#10;            { text: '字段', textStyle: { bold: true, color: '#FFFFFF' }, cellStyle: { background: { color: '#1B4F9C' } } },&#10;            { text: '含义', textStyle: { bold: true, color: '#FFFFFF' }, cellStyle: { background: { color: '#1B4F9C' } } },&#10;          ],&#10;          [&#10;            { text: 'enabled', textStyle: { bold: true, color: '#1B4F9C' } },&#10;            'false → 整段跳过（这门课可以不要讨论）',&#10;          ],&#10;          [&#10;            { text: 'minutes', textStyle: { bold: true, color: '#1B4F9C' }, cellStyle: { background: { color: '#E8F0FB' } } },&#10;            { text: '这一幕的时长预算，真实时钟到点切幕', cellStyle: { background: { color: '#E8F0FB' } } },&#10;          ],&#10;          [&#10;            { text: 'advance_when', textStyle: { bold: true, color: '#1B4F9C' } },&#10;            'either 证据或时间 / evidence 学透才走 / budget 只看时间',&#10;          ],&#10;        ]}&#10;      /&gt;&#10;      &lt;Box style={{ background: '#E8F0FB', borderRadius: 10, padding: '14px 18px', marginTop: 'auto' }}&gt;&#10;        &lt;Text style={{ fontSize: 14.5, color: '#0F2E5C', lineHeight: 1.65 }}&gt;&#10;          &lt;span style={{ fontWeight: 'bold', color: '#1B4F9C' }}&gt;改 JSON 就是改课。&lt;/span&gt;加一幕、砍一幕、调整分钟数，都不用碰任何代码与提示词 —— 状态机每轮读这张表。&#10;        &lt;/Text&gt;&#10;      &lt;/Box&gt;&#10;    &lt;/Box&gt;&#10;  &lt;/Box&gt;&#10;  &lt;Box style={{ position: 'absolute', left: 64, right: 64, bottom: 20, flexDirection: 'row', justifyContent: 'space-between' }}&gt;&#10;    &lt;Box style={{ flexDirection: 'row', alignItems: 'center', gap: 8 }}&gt;&#10;      &lt;Box style={{ width: 10, height: 10, background: '#1B4F9C', borderRadius: 2 }} /&gt;&#10;      &lt;Text style={{ fontSize: 13, color: '#64748B' }}&gt;主动引导智能体 · 项目介绍&lt;/Text&gt;&#10;    &lt;/Box&gt;&#10;    &lt;Text style={{ fontSize: 13, color: '#64748B' }}&gt;07 / 18&lt;/Text&gt;&#10;  &lt;/Box&gt;&#10;&lt;/Slide&gt;&#10;"/>
         <p:cNvGrpSpPr/>
         <p:nvPr/>
       </p:nvGrpSpPr>
@@ -17420,7 +17420,7 @@
                 <a:latin typeface="Menlo"/>
                 <a:ea typeface="Menlo"/>
               </a:rPr>
-              <a:t>"ch3-process-scheduling"</a:t>
+              <a:t>"example-week-1"</a:t>
             </a:r>
             <a:r>
               <a:rPr sz="940">

</xml_diff>